<commit_message>
Slide 7: swap to GMM equal-prior confusion matrix (direct GMM output, unbiased)
</commit_message>
<xml_diff>
--- a/docs/CFTR_cryoDRGN_presentation.pptx
+++ b/docs/CFTR_cryoDRGN_presentation.pptx
@@ -1696,7 +1696,7 @@
           <a:p/>
           <a:p>
             <a:r>
-              <a:t>RIGHT: The confusion matrix quantifies this exactly. Diagonal 0.40/0.31/0.38 confirms signal; off-diagonal 0.29–0.36 confirms overlap.</a:t>
+              <a:t>RIGHT: The GMM equal-prior confusion matrix. This IS the direct output of the GMM model. Under an equal-prior decision rule (no weight bias) the diagonal is P6=0.87, P7=0.69, P8=0.59. "Equal-prior" means we ask: ignoring how many particles are in each class, if we sampled a new particle from each Gaussian component, how often would it be classified back to the right class? This measures pure Gaussian geometry. P7 and P8 each have ~30-40% confusion with other classes — confirming they're the most overlapping states — while P6 is the most distinct (87% self-assignment).</a:t>
             </a:r>
           </a:p>
           <a:p/>
@@ -11882,7 +11882,7 @@
       </p:sp>
       <p:pic>
         <p:nvPicPr>
-          <p:cNvPr id="8" name="Picture 7" descr="confusion_soft_posterior.png"/>
+          <p:cNvPr id="8" name="Picture 7" descr="confusion_gmm_equalprior.png"/>
           <p:cNvPicPr>
             <a:picLocks noChangeAspect="1"/>
           </p:cNvPicPr>
@@ -11913,7 +11913,7 @@
         <p:spPr>
           <a:xfrm>
             <a:off x="7726679" y="4206240"/>
-            <a:ext cx="4251960" cy="1691640"/>
+            <a:ext cx="4251960" cy="2103120"/>
           </a:xfrm>
           <a:prstGeom prst="rect">
             <a:avLst/>
@@ -11958,7 +11958,7 @@
         <p:spPr>
           <a:xfrm>
             <a:off x="7799831" y="4251959"/>
-            <a:ext cx="4105656" cy="1600200"/>
+            <a:ext cx="4105656" cy="2011679"/>
           </a:xfrm>
           <a:prstGeom prst="rect">
             <a:avLst/>
@@ -11978,7 +11978,7 @@
                   <a:srgbClr val="404040"/>
                 </a:solidFill>
               </a:rPr>
-              <a:t>Soft-posterior confusion (GMM pipeline).</a:t>
+              <a:t>GMM equal-prior confusion — the GMM fit output.</a:t>
             </a:r>
           </a:p>
           <a:p>
@@ -11989,7 +11989,7 @@
                   <a:srgbClr val="404040"/>
                 </a:solidFill>
               </a:rPr>
-              <a:t>P6 diagonal 0.40, P7 = 0.31, P8 = 0.38.</a:t>
+              <a:t>Rows = CryoSPARC class; cols = GMM hard assignment</a:t>
             </a:r>
           </a:p>
           <a:p>
@@ -12000,7 +12000,7 @@
                   <a:srgbClr val="404040"/>
                 </a:solidFill>
               </a:rPr>
-              <a:t>All &gt; 0.33 baseline → REAL class signal.</a:t>
+              <a:t>under equal-prior decision rule (pure geometry).</a:t>
             </a:r>
           </a:p>
           <a:p>
@@ -12011,7 +12011,7 @@
                   <a:srgbClr val="404040"/>
                 </a:solidFill>
               </a:rPr>
-              <a:t>Off-diagonal 0.29–0.36 → genuine overlap.</a:t>
+              <a:t>P6 diagonal 0.87 → well-separated in GMM space.</a:t>
             </a:r>
           </a:p>
           <a:p>
@@ -12022,7 +12022,7 @@
                   <a:srgbClr val="404040"/>
                 </a:solidFill>
               </a:rPr>
-              <a:t>Note: axis label 'True' is a misnomer here</a:t>
+              <a:t>P7 = 0.69, P8 = 0.59 → more GMM overlap, P7/P8</a:t>
             </a:r>
           </a:p>
           <a:p>
@@ -12033,7 +12033,7 @@
                   <a:srgbClr val="404040"/>
                 </a:solidFill>
               </a:rPr>
-              <a:t>— both are observed, not ground truth.</a:t>
+              <a:t>share a region of the ALR-posterior landscape.</a:t>
             </a:r>
           </a:p>
           <a:p>
@@ -12055,7 +12055,7 @@
                   <a:srgbClr val="404040"/>
                 </a:solidFill>
               </a:rPr>
-              <a:t>GMM formula:  p(x) = Σₖ πₖ · 𝒩(x ; μₖ, Σₖ)</a:t>
+              <a:t>This is the DIRECT output of fitting the Gaussian</a:t>
             </a:r>
           </a:p>
           <a:p>
@@ -12066,7 +12066,18 @@
                   <a:srgbClr val="404040"/>
                 </a:solidFill>
               </a:rPr>
-              <a:t>Fit to ALR-transformed probability vectors.</a:t>
+              <a:t>Mixture Model — how well the 3 fitted Gaussians</a:t>
+            </a:r>
+          </a:p>
+          <a:p>
+            <a:pPr algn="l"/>
+            <a:r>
+              <a:rPr sz="1000" b="0" i="1">
+                <a:solidFill>
+                  <a:srgbClr val="404040"/>
+                </a:solidFill>
+              </a:rPr>
+              <a:t>separate under an unbiased equal-prior rule.</a:t>
             </a:r>
           </a:p>
         </p:txBody>

</xml_diff>

<commit_message>
Slide 9: replace circular latent-GMM self-confusion with honest 81% cross-method agreement
</commit_message>
<xml_diff>
--- a/docs/CFTR_cryoDRGN_presentation.pptx
+++ b/docs/CFTR_cryoDRGN_presentation.pptx
@@ -1944,19 +1944,13 @@
           <a:p/>
           <a:p>
             <a:r>
-              <a:t>RIGHT: The confusion matrix of the latent GMM. Look at the diagonal: 0.97, 0.96, 0.99. Compare this to CryoSPARC's debiased confusion from slide 7: 0.40, 0.31, 0.38. </a:t>
+              <a:t>RIGHT: The confusion matrix in the top-right is the CROSS-METHOD agreement between CryoSPARC and cryoDRGN — NOT the latent GMM measuring itself. Each row is a CryoSPARC class; each column is what cryoDRGN's latent GMM assigned the same particle to. 81.2% of particles get the same label from both methods. That's the honest number — and it's meaningful: if the two methods were completely unrelated, you'd expect 33% agreement by random chance. Getting 81% from two algorithms with completely different assumptions is strong cross-validation.</a:t>
             </a:r>
           </a:p>
           <a:p/>
           <a:p>
             <a:r>
-              <a:t>CryoSPARC sees substantial particle-level confusion between the three classes. cryoDRGN's latent space has essentially zero confusion. The neural network is finding a representation where the three states are cleanly separated — far more so than in the CryoSPARC posterior space.</a:t>
-            </a:r>
-          </a:p>
-          <a:p/>
-          <a:p>
-            <a:r>
-              <a:t>This doesn't mean CryoSPARC is wrong — it means cryoDRGN's latent geometry is better suited to discriminating these particular structural differences. And crucially, both find the SAME three classes. That cross-validation is our strongest result.</a:t>
+              <a:t>IMPORTANT: I'm NOT showing the latent GMM self-confusion (which was 0.97/0.96/0.99). That number is CIRCULAR — the GMM was fitted to the latent data and then evaluated on the same data. With 2.60 SD separation, the Gaussian likelihoods are nearly binary, so the GMM artificially gives near-perfect confidence to itself. That tells you nothing about whether the classes are real — it just confirms the GMM fit tightly. Comparing that 0.97/0.99 to CryoSPARC's honest 0.40/0.38 is an unfair comparison; I've replaced it with the cross-method agreement (81%) which is the honest metric.</a:t>
             </a:r>
           </a:p>
         </p:txBody>
@@ -14025,7 +14019,7 @@
       </p:pic>
       <p:pic>
         <p:nvPicPr>
-          <p:cNvPr id="7" name="Picture 6" descr="latent_confusion_soft.png"/>
+          <p:cNvPr id="7" name="Picture 6" descr="confusion.png"/>
           <p:cNvPicPr>
             <a:picLocks noChangeAspect="1"/>
           </p:cNvPicPr>
@@ -14040,7 +14034,7 @@
         <p:spPr>
           <a:xfrm>
             <a:off x="9921240" y="1051560"/>
-            <a:ext cx="2084831" cy="1935914"/>
+            <a:ext cx="2084831" cy="1681261"/>
           </a:xfrm>
           <a:prstGeom prst="rect">
             <a:avLst/>
@@ -14334,7 +14328,7 @@
                   <a:srgbClr val="404040"/>
                 </a:solidFill>
               </a:rPr>
-              <a:t>RIGHT: Latent GMM confusion.</a:t>
+              <a:t>RIGHT: Cross-method agreement.</a:t>
             </a:r>
           </a:p>
           <a:p>
@@ -14345,7 +14339,7 @@
                   <a:srgbClr val="404040"/>
                 </a:solidFill>
               </a:rPr>
-              <a:t>Diagonal 0.97 / 0.96 / 0.99 !</a:t>
+              <a:t>CryoSPARC class (row) vs cryoDRGN</a:t>
             </a:r>
           </a:p>
           <a:p>
@@ -14356,7 +14350,7 @@
                   <a:srgbClr val="404040"/>
                 </a:solidFill>
               </a:rPr>
-              <a:t>vs CryoSPARC: 0.40 / 0.31 / 0.38</a:t>
+              <a:t>latent hard assignment (col).</a:t>
             </a:r>
           </a:p>
           <a:p>
@@ -14367,7 +14361,40 @@
                   <a:srgbClr val="404040"/>
                 </a:solidFill>
               </a:rPr>
-              <a:t>→ Dramatic improvement.</a:t>
+              <a:t>81.2% overall agreement (vs 33%</a:t>
+            </a:r>
+          </a:p>
+          <a:p>
+            <a:pPr algn="l"/>
+            <a:r>
+              <a:rPr sz="1000" b="0" i="1">
+                <a:solidFill>
+                  <a:srgbClr val="404040"/>
+                </a:solidFill>
+              </a:rPr>
+              <a:t>random baseline for 3 classes).</a:t>
+            </a:r>
+          </a:p>
+          <a:p>
+            <a:pPr algn="l"/>
+            <a:r>
+              <a:rPr sz="1000" b="0" i="1">
+                <a:solidFill>
+                  <a:srgbClr val="404040"/>
+                </a:solidFill>
+              </a:rPr>
+              <a:t>Both methods are independent —</a:t>
+            </a:r>
+          </a:p>
+          <a:p>
+            <a:pPr algn="l"/>
+            <a:r>
+              <a:rPr sz="1000" b="0" i="1">
+                <a:solidFill>
+                  <a:srgbClr val="404040"/>
+                </a:solidFill>
+              </a:rPr>
+              <a:t>neither is ground truth.</a:t>
             </a:r>
           </a:p>
         </p:txBody>
@@ -14444,7 +14471,7 @@
                   <a:srgbClr val="FFFFFF"/>
                 </a:solidFill>
               </a:rPr>
-              <a:t>Same 3 classes as CryoSPARC — found WITHOUT reference maps. Latent-GMM confusion (0.97–0.99) vs CryoSPARC (0.40–0.38) = cryoDRGN cleanly resolves what CryoSPARC genuinely struggles with.</a:t>
+              <a:t>Same 3 classes as CryoSPARC — found WITHOUT reference maps. Cross-method agreement 81% (vs 33% random) = independent validation; neither method is ground truth.</a:t>
             </a:r>
           </a:p>
         </p:txBody>

</xml_diff>

<commit_message>
Slide 10: show PC1 marginal + occupancy matrix (panel C only, no C. label)
</commit_message>
<xml_diff>
--- a/docs/CFTR_cryoDRGN_presentation.pptx
+++ b/docs/CFTR_cryoDRGN_presentation.pptx
@@ -5340,7 +5340,7 @@
         <p:spPr>
           <a:xfrm>
             <a:off x="182880" y="1051560"/>
-            <a:ext cx="5303520" cy="3314700"/>
+            <a:ext cx="5669280" cy="3543300"/>
           </a:xfrm>
           <a:prstGeom prst="rect">
             <a:avLst/>
@@ -5349,7 +5349,7 @@
       </p:pic>
       <p:pic>
         <p:nvPicPr>
-          <p:cNvPr id="6" name="Picture 5" descr="basin_occupancy_J1442x5.png"/>
+          <p:cNvPr id="6" name="Picture 5" descr="panel_C_occupancy.png"/>
           <p:cNvPicPr>
             <a:picLocks noChangeAspect="1"/>
           </p:cNvPicPr>
@@ -5363,8 +5363,8 @@
         </p:blipFill>
         <p:spPr>
           <a:xfrm>
-            <a:off x="5577840" y="1051560"/>
-            <a:ext cx="6400800" cy="5120640"/>
+            <a:off x="6035040" y="1051560"/>
+            <a:ext cx="5943600" cy="4754880"/>
           </a:xfrm>
           <a:prstGeom prst="rect">
             <a:avLst/>
@@ -5380,7 +5380,7 @@
         <p:spPr>
           <a:xfrm>
             <a:off x="182880" y="6007608"/>
-            <a:ext cx="5303520" cy="804672"/>
+            <a:ext cx="5669280" cy="804672"/>
           </a:xfrm>
           <a:prstGeom prst="rect">
             <a:avLst/>
@@ -5425,7 +5425,7 @@
         <p:spPr>
           <a:xfrm>
             <a:off x="256032" y="6053328"/>
-            <a:ext cx="5157216" cy="713232"/>
+            <a:ext cx="5522976" cy="713232"/>
           </a:xfrm>
           <a:prstGeom prst="rect">
             <a:avLst/>
@@ -5502,8 +5502,8 @@
         </p:nvSpPr>
         <p:spPr>
           <a:xfrm>
-            <a:off x="5577840" y="6007608"/>
-            <a:ext cx="6400800" cy="804672"/>
+            <a:off x="6035040" y="6007608"/>
+            <a:ext cx="5943600" cy="804672"/>
           </a:xfrm>
           <a:prstGeom prst="rect">
             <a:avLst/>
@@ -5547,8 +5547,8 @@
         </p:nvSpPr>
         <p:spPr>
           <a:xfrm>
-            <a:off x="5650992" y="6053328"/>
-            <a:ext cx="6254496" cy="713232"/>
+            <a:off x="6108192" y="6053328"/>
+            <a:ext cx="5797296" cy="713232"/>
           </a:xfrm>
           <a:prstGeom prst="rect">
             <a:avLst/>
@@ -5568,7 +5568,7 @@
                   <a:srgbClr val="404040"/>
                 </a:solidFill>
               </a:rPr>
-              <a:t>RIGHT: 2D free-energy basin analysis F(PC1,PC2) = -log[probability density].</a:t>
+              <a:t>RIGHT: Occupancy matrix P(basin | CryoSPARC class).</a:t>
             </a:r>
           </a:p>
           <a:p>
@@ -5579,7 +5579,7 @@
                   <a:srgbClr val="404040"/>
                 </a:solidFill>
               </a:rPr>
-              <a:t>A: 3 energy wells (⭐=minima; bright yellow=stable, dark=unstable/unpopulated).</a:t>
+              <a:t>Rows = CryoSPARC class; columns = free-energy basin.</a:t>
             </a:r>
           </a:p>
           <a:p>
@@ -5590,7 +5590,7 @@
                   <a:srgbClr val="404040"/>
                 </a:solidFill>
               </a:rPr>
-              <a:t>B: Watershed boundaries — 3 coloured basins, each capturing one CryoSPARC class.</a:t>
+              <a:t>Block-diagonal structure: P6→B1 (91%), P7→B2 (69%),</a:t>
             </a:r>
           </a:p>
           <a:p>
@@ -5601,7 +5601,7 @@
                   <a:srgbClr val="404040"/>
                 </a:solidFill>
               </a:rPr>
-              <a:t>C: Occupancy matrix — P6→Basin1 (91%), P7→Basin2 (69%), P8→Basin3 (85%).</a:t>
+              <a:t>P8→B3 (85%). P9 and P10 also segregate to B3 and B1</a:t>
             </a:r>
           </a:p>
           <a:p>
@@ -5612,7 +5612,18 @@
                   <a:srgbClr val="404040"/>
                 </a:solidFill>
               </a:rPr>
-              <a:t>D: Basin count = 3 is stable across 0.5–1.3 kT barrier thresholds (robust!).</a:t>
+              <a:t>respectively, matching their substate relationship</a:t>
+            </a:r>
+          </a:p>
+          <a:p>
+            <a:pPr algn="l"/>
+            <a:r>
+              <a:rPr sz="1000" b="0" i="1">
+                <a:solidFill>
+                  <a:srgbClr val="404040"/>
+                </a:solidFill>
+              </a:rPr>
+              <a:t>with P8 and P6.</a:t>
             </a:r>
           </a:p>
         </p:txBody>

</xml_diff>